<commit_message>
Update Final Capstone Presentation.pptx
</commit_message>
<xml_diff>
--- a/docs/presentations/Final Presentation/Final Capstone Presentation.pptx
+++ b/docs/presentations/Final Presentation/Final Capstone Presentation.pptx
@@ -4437,28 +4437,67 @@
             <a:pPr marL="0" indent="0">
               <a:buNone/>
             </a:pPr>
+            <a:endParaRPr lang="en-US" dirty="0"/>
+          </a:p>
+          <a:p>
+            <a:pPr marL="0" indent="0">
+              <a:buNone/>
+            </a:pPr>
+            <a:endParaRPr lang="en-US" dirty="0"/>
+          </a:p>
+          <a:p>
+            <a:pPr marL="0" indent="0">
+              <a:buNone/>
+            </a:pPr>
+            <a:endParaRPr lang="en-US" dirty="0"/>
+          </a:p>
+          <a:p>
+            <a:pPr marL="0" indent="0">
+              <a:buNone/>
+            </a:pPr>
             <a:r>
               <a:rPr lang="en-US" dirty="0">
                 <a:hlinkClick r:id="rId2"/>
               </a:rPr>
+              <a:t>Demo Vid</a:t>
+            </a:r>
+            <a:r>
+              <a:rPr lang="en-US" dirty="0"/>
+              <a:t> (OneDrive)</a:t>
+            </a:r>
+          </a:p>
+          <a:p>
+            <a:pPr marL="0" indent="0">
+              <a:buNone/>
+            </a:pPr>
+            <a:endParaRPr lang="en-US" dirty="0"/>
+          </a:p>
+          <a:p>
+            <a:pPr marL="0" indent="0">
+              <a:buNone/>
+            </a:pPr>
+            <a:endParaRPr lang="en-US" dirty="0"/>
+          </a:p>
+          <a:p>
+            <a:pPr marL="0" indent="0">
+              <a:buNone/>
+            </a:pPr>
+            <a:endParaRPr lang="en-US" dirty="0"/>
+          </a:p>
+          <a:p>
+            <a:pPr marL="0" indent="0">
+              <a:buNone/>
+            </a:pPr>
+            <a:r>
+              <a:rPr lang="en-US" dirty="0">
+                <a:hlinkClick r:id="rId3"/>
+              </a:rPr>
               <a:t>https://nettower.org</a:t>
             </a:r>
             <a:r>
               <a:rPr lang="en-US" dirty="0"/>
               <a:t> </a:t>
             </a:r>
-          </a:p>
-          <a:p>
-            <a:pPr marL="0" indent="0">
-              <a:buNone/>
-            </a:pPr>
-            <a:endParaRPr lang="en-US" dirty="0"/>
-          </a:p>
-          <a:p>
-            <a:pPr marL="0" indent="0">
-              <a:buNone/>
-            </a:pPr>
-            <a:endParaRPr lang="en-US" dirty="0"/>
           </a:p>
         </p:txBody>
       </p:sp>

</xml_diff>